<commit_message>
Presentation: 12-slide deck (Slides artifact) on the user's A2 -> A1 -> A3 -> A4 storyline
- presentation/artifact_deck/: slide sources of https://claude.ai/artifact/1MvjUtpP31R3vVrVGLWftc
- presentation/artifact_figures.py + artifact_figs/: equations and figures from instances/ and results/ (v2)
- model B mechanism (M_seed0 real shots), A3 layout, A4 laser grid, results vs random guessing
- PPTX builder kept (build_deck.py; earlier versions build_deck_v2.py, charts_v2.py)

Co-Authored-By: Claude Opus 5.5 <noreply@anthropic.com>
Claude-Session: https://claude.ai/code/session_01LXAyM1dmodK9nQJJophB4z
</commit_message>
<xml_diff>
--- a/presentation/TrackA_7min_MOCK.pptx
+++ b/presentation/TrackA_7min_MOCK.pptx
@@ -4469,7 +4469,7 @@
               </a:defRPr>
             </a:pPr>
             <a:r>
-              <a:t>Workflow: A2 instances → A1 loss → A3 atom distances → A4 pulse. Model B counts are a direction under test.</a:t>
+              <a:t>Workflow: A2 instances → A1 loss → A3 atom distances → A4 pulse. Model B is the working pipeline; the direct QUBO is the baseline.</a:t>
             </a:r>
           </a:p>
         </p:txBody>
@@ -5810,8 +5810,8 @@
         </p:blipFill>
         <p:spPr>
           <a:xfrm>
-            <a:off x="2143906" y="2423160"/>
-            <a:ext cx="10342586" cy="3291840"/>
+            <a:off x="2275425" y="2423159"/>
+            <a:ext cx="10079549" cy="3291840"/>
           </a:xfrm>
           <a:prstGeom prst="rect">
             <a:avLst/>
@@ -5827,7 +5827,62 @@
         <p:spPr>
           <a:xfrm>
             <a:off x="868680" y="5715000"/>
-            <a:ext cx="4069080" cy="1051560"/>
+            <a:ext cx="3931920" cy="1051560"/>
+          </a:xfrm>
+          <a:prstGeom prst="rect">
+            <a:avLst/>
+          </a:prstGeom>
+          <a:noFill/>
+        </p:spPr>
+        <p:txBody>
+          <a:bodyPr wrap="square" lIns="0" rIns="0" tIns="0" bIns="0">
+            <a:spAutoFit/>
+          </a:bodyPr>
+          <a:lstStyle/>
+          <a:p>
+            <a:pPr>
+              <a:spcAft>
+                <a:spcPts val="900"/>
+              </a:spcAft>
+              <a:defRPr sz="1800" b="0">
+                <a:solidFill>
+                  <a:srgbClr val="59616A"/>
+                </a:solidFill>
+                <a:latin typeface="Arial"/>
+              </a:defRPr>
+            </a:pPr>
+            <a:r>
+              <a:t>We set: δ (laser) and r (positions).</a:t>
+            </a:r>
+          </a:p>
+          <a:p>
+            <a:pPr>
+              <a:spcAft>
+                <a:spcPts val="900"/>
+              </a:spcAft>
+              <a:defRPr sz="1800" b="0">
+                <a:solidFill>
+                  <a:srgbClr val="59616A"/>
+                </a:solidFill>
+                <a:latin typeface="Arial"/>
+              </a:defRPr>
+            </a:pPr>
+            <a:r>
+              <a:t>We cannot set: C₆, the 1/r⁶ law.</a:t>
+            </a:r>
+          </a:p>
+        </p:txBody>
+      </p:sp>
+      <p:sp>
+        <p:nvSpPr>
+          <p:cNvPr id="11" name="TextBox 10"/>
+          <p:cNvSpPr txBox="1"/>
+          <p:nvPr/>
+        </p:nvSpPr>
+        <p:spPr>
+          <a:xfrm>
+            <a:off x="5120640" y="5715000"/>
+            <a:ext cx="4160520" cy="1051560"/>
           </a:xfrm>
           <a:prstGeom prst="rect">
             <a:avLst/>
@@ -5846,13 +5901,13 @@
               </a:spcAft>
               <a:defRPr sz="2000" b="1">
                 <a:solidFill>
-                  <a:srgbClr val="26805D"/>
+                  <a:srgbClr val="B5443C"/>
                 </a:solidFill>
                 <a:latin typeface="Arial"/>
               </a:defRPr>
             </a:pPr>
             <a:r>
-              <a:t>MATCH: positive pair sign.</a:t>
+              <a:t>MISMATCH: each atom wants its</a:t>
             </a:r>
           </a:p>
           <a:p>
@@ -5862,27 +5917,27 @@
               </a:spcAft>
               <a:defRPr sz="2000" b="1">
                 <a:solidFill>
-                  <a:srgbClr val="26805D"/>
+                  <a:srgbClr val="B5443C"/>
                 </a:solidFill>
                 <a:latin typeface="Arial"/>
               </a:defRPr>
             </a:pPr>
             <a:r>
-              <a:t>Values still need a joint 2D fit.</a:t>
-            </a:r>
-          </a:p>
-        </p:txBody>
-      </p:sp>
-      <p:sp>
-        <p:nvSpPr>
-          <p:cNvPr id="11" name="TextBox 10"/>
+              <a:t>own aₐ; the laser gives one −δ.</a:t>
+            </a:r>
+          </a:p>
+        </p:txBody>
+      </p:sp>
+      <p:sp>
+        <p:nvSpPr>
+          <p:cNvPr id="12" name="TextBox 11"/>
           <p:cNvSpPr txBox="1"/>
           <p:nvPr/>
         </p:nvSpPr>
         <p:spPr>
           <a:xfrm>
-            <a:off x="5120640" y="5715000"/>
-            <a:ext cx="4160520" cy="1051560"/>
+            <a:off x="9509760" y="5715000"/>
+            <a:ext cx="4480560" cy="457200"/>
           </a:xfrm>
           <a:prstGeom prst="rect">
             <a:avLst/>
@@ -5901,15 +5956,38 @@
               </a:spcAft>
               <a:defRPr sz="2000" b="1">
                 <a:solidFill>
-                  <a:srgbClr val="B5443C"/>
+                  <a:srgbClr val="26805D"/>
                 </a:solidFill>
                 <a:latin typeface="Arial"/>
               </a:defRPr>
             </a:pPr>
             <a:r>
-              <a:t>MISMATCH: nonuniform aₐ</a:t>
-            </a:r>
-          </a:p>
+              <a:t>MATCH: both always positive.</a:t>
+            </a:r>
+          </a:p>
+        </p:txBody>
+      </p:sp>
+      <p:sp>
+        <p:nvSpPr>
+          <p:cNvPr id="13" name="TextBox 12"/>
+          <p:cNvSpPr txBox="1"/>
+          <p:nvPr/>
+        </p:nvSpPr>
+        <p:spPr>
+          <a:xfrm>
+            <a:off x="9509760" y="6172200"/>
+            <a:ext cx="4480560" cy="822960"/>
+          </a:xfrm>
+          <a:prstGeom prst="rect">
+            <a:avLst/>
+          </a:prstGeom>
+          <a:noFill/>
+        </p:spPr>
+        <p:txBody>
+          <a:bodyPr wrap="square" lIns="0" rIns="0" tIns="0" bIns="0">
+            <a:spAutoFit/>
+          </a:bodyPr>
+          <a:lstStyle/>
           <a:p>
             <a:pPr>
               <a:spcAft>
@@ -5923,32 +6001,9 @@
               </a:defRPr>
             </a:pPr>
             <a:r>
-              <a:t>versus one global −δ.</a:t>
-            </a:r>
-          </a:p>
-        </p:txBody>
-      </p:sp>
-      <p:sp>
-        <p:nvSpPr>
-          <p:cNvPr id="12" name="TextBox 11"/>
-          <p:cNvSpPr txBox="1"/>
-          <p:nvPr/>
-        </p:nvSpPr>
-        <p:spPr>
-          <a:xfrm>
-            <a:off x="9509760" y="5715000"/>
-            <a:ext cx="4297680" cy="1051560"/>
-          </a:xfrm>
-          <a:prstGeom prst="rect">
-            <a:avLst/>
-          </a:prstGeom>
-          <a:noFill/>
-        </p:spPr>
-        <p:txBody>
-          <a:bodyPr wrap="square" lIns="0" rIns="0" tIns="0" bIns="0">
-            <a:spAutoFit/>
-          </a:bodyPr>
-          <a:lstStyle/>
+              <a:t>MISMATCH: some pairs want 0;</a:t>
+            </a:r>
+          </a:p>
           <a:p>
             <a:pPr>
               <a:spcAft>
@@ -5962,30 +6017,14 @@
               </a:defRPr>
             </a:pPr>
             <a:r>
-              <a:t>MISMATCH: target-zero pairs</a:t>
-            </a:r>
-          </a:p>
-          <a:p>
-            <a:pPr>
-              <a:spcAft>
-                <a:spcPts val="900"/>
-              </a:spcAft>
-              <a:defRPr sz="2000" b="1">
-                <a:solidFill>
-                  <a:srgbClr val="B5443C"/>
-                </a:solidFill>
-                <a:latin typeface="Arial"/>
-              </a:defRPr>
-            </a:pPr>
-            <a:r>
-              <a:t>and many strong partners.</a:t>
-            </a:r>
-          </a:p>
-        </p:txBody>
-      </p:sp>
-      <p:sp>
-        <p:nvSpPr>
-          <p:cNvPr id="13" name="TextBox 12"/>
+              <a:t>each M atom wants 11 partners.</a:t>
+            </a:r>
+          </a:p>
+        </p:txBody>
+      </p:sp>
+      <p:sp>
+        <p:nvSpPr>
+          <p:cNvPr id="14" name="TextBox 13"/>
           <p:cNvSpPr txBox="1"/>
           <p:nvPr/>
         </p:nvSpPr>
@@ -6121,7 +6160,7 @@
               </a:defRPr>
             </a:pPr>
             <a:r>
-              <a:t>Fit the energy ranking, not just each distance.</a:t>
+              <a:t>Atom distance: the direct QUBO asks for an impossible layout.</a:t>
             </a:r>
           </a:p>
         </p:txBody>
@@ -6160,7 +6199,7 @@
               </a:defRPr>
             </a:pPr>
             <a:r>
-              <a:t>rₐᵦ* = (C₆ / Uₐᵦ*)¹⁄⁶, with U* = s b. Minimum spacing 5 µm; register radius ≤ 38 µm.</a:t>
+              <a:t>Wanted distance rₐᵦ = (C₆ / Uₐᵦ)¹⁄⁶. Device: spacing ≥ 5 µm (red line), radius ≤ 38 µm.</a:t>
             </a:r>
           </a:p>
         </p:txBody>
@@ -6345,8 +6384,8 @@
         </p:blipFill>
         <p:spPr>
           <a:xfrm>
-            <a:off x="731520" y="2998177"/>
-            <a:ext cx="6400800" cy="2727021"/>
+            <a:off x="685800" y="2603831"/>
+            <a:ext cx="7863840" cy="3479136"/>
           </a:xfrm>
           <a:prstGeom prst="rect">
             <a:avLst/>
@@ -6361,8 +6400,8 @@
         </p:nvSpPr>
         <p:spPr>
           <a:xfrm>
-            <a:off x="7360920" y="2697480"/>
-            <a:ext cx="6400800" cy="548640"/>
+            <a:off x="8778240" y="2651760"/>
+            <a:ext cx="5120640" cy="548640"/>
           </a:xfrm>
           <a:prstGeom prst="rect">
             <a:avLst/>
@@ -6379,7 +6418,7 @@
               <a:spcAft>
                 <a:spcPts val="900"/>
               </a:spcAft>
-              <a:defRPr sz="2400" b="1">
+              <a:defRPr sz="2300" b="1">
                 <a:solidFill>
                   <a:srgbClr val="B5443C"/>
                 </a:solidFill>
@@ -6387,7 +6426,7 @@
               </a:defRPr>
             </a:pPr>
             <a:r>
-              <a:t>Dense baseline: a measured limit</a:t>
+              <a:t>Model A: measured limit</a:t>
             </a:r>
           </a:p>
         </p:txBody>
@@ -6400,8 +6439,8 @@
         </p:nvSpPr>
         <p:spPr>
           <a:xfrm>
-            <a:off x="7360920" y="3364992"/>
-            <a:ext cx="6217920" cy="1188720"/>
+            <a:off x="8778240" y="3246120"/>
+            <a:ext cx="5120640" cy="1280160"/>
           </a:xfrm>
           <a:prstGeom prst="rect">
             <a:avLst/>
@@ -6420,13 +6459,13 @@
               </a:spcAft>
               <a:defRPr sz="1900" b="0">
                 <a:solidFill>
-                  <a:srgbClr val="59616A"/>
+                  <a:srgbClr val="24292F"/>
                 </a:solidFill>
                 <a:latin typeface="Arial"/>
               </a:defRPr>
             </a:pPr>
             <a:r>
-              <a:t>PLAN §6 reports M ranks ≈10⁴ / 59,049</a:t>
+              <a:t>Too many pairs want the same</a:t>
             </a:r>
           </a:p>
           <a:p>
@@ -6436,13 +6475,13 @@
               </a:spcAft>
               <a:defRPr sz="1900" b="0">
                 <a:solidFill>
-                  <a:srgbClr val="59616A"/>
+                  <a:srgbClr val="24292F"/>
                 </a:solidFill>
                 <a:latin typeface="Arial"/>
               </a:defRPr>
             </a:pPr>
             <a:r>
-              <a:t>assignment-valid states; coupling error η ≈ 1.</a:t>
+              <a:t>short distance. M: true optimum</a:t>
             </a:r>
           </a:p>
           <a:p>
@@ -6452,13 +6491,13 @@
               </a:spcAft>
               <a:defRPr sz="1900" b="0">
                 <a:solidFill>
-                  <a:srgbClr val="59616A"/>
+                  <a:srgbClr val="24292F"/>
                 </a:solidFill>
                 <a:latin typeface="Arial"/>
               </a:defRPr>
             </a:pPr>
             <a:r>
-              <a:t>Approximate logged findings, not new runs.</a:t>
+              <a:t>ranks ≈10⁴ of 59,049; η ≈ 1.</a:t>
             </a:r>
           </a:p>
         </p:txBody>
@@ -6471,8 +6510,8 @@
         </p:nvSpPr>
         <p:spPr>
           <a:xfrm>
-            <a:off x="7360920" y="4754880"/>
-            <a:ext cx="6217920" cy="1508760"/>
+            <a:off x="8778240" y="4572000"/>
+            <a:ext cx="5120640" cy="548640"/>
           </a:xfrm>
           <a:prstGeom prst="rect">
             <a:avLst/>
@@ -6489,31 +6528,54 @@
               <a:spcAft>
                 <a:spcPts val="900"/>
               </a:spcAft>
-              <a:defRPr sz="2000" b="0">
-                <a:solidFill>
-                  <a:srgbClr val="245B94"/>
+              <a:defRPr sz="2300" b="1">
+                <a:solidFill>
+                  <a:srgbClr val="26805D"/>
                 </a:solidFill>
                 <a:latin typeface="Arial"/>
               </a:defRPr>
             </a:pPr>
             <a:r>
-              <a:t>Next: model B — N seed atoms.</a:t>
-            </a:r>
-          </a:p>
+              <a:t>Model B: atoms = customer map</a:t>
+            </a:r>
+          </a:p>
+        </p:txBody>
+      </p:sp>
+      <p:sp>
+        <p:nvSpPr>
+          <p:cNvPr id="13" name="TextBox 12"/>
+          <p:cNvSpPr txBox="1"/>
+          <p:nvPr/>
+        </p:nvSpPr>
+        <p:spPr>
+          <a:xfrm>
+            <a:off x="8778240" y="5166360"/>
+            <a:ext cx="5120640" cy="1005840"/>
+          </a:xfrm>
+          <a:prstGeom prst="rect">
+            <a:avLst/>
+          </a:prstGeom>
+          <a:noFill/>
+        </p:spPr>
+        <p:txBody>
+          <a:bodyPr wrap="square" lIns="0" rIns="0" tIns="0" bIns="0">
+            <a:spAutoFit/>
+          </a:bodyPr>
+          <a:lstStyle/>
           <a:p>
             <a:pPr>
               <a:spcAft>
                 <a:spcPts val="900"/>
               </a:spcAft>
-              <a:defRPr sz="2000" b="0">
-                <a:solidFill>
-                  <a:srgbClr val="245B94"/>
+              <a:defRPr sz="1900" b="0">
+                <a:solidFill>
+                  <a:srgbClr val="24292F"/>
                 </a:solidFill>
                 <a:latin typeface="Arial"/>
               </a:defRPr>
             </a:pPr>
             <a:r>
-              <a:t>Energy selects spread-out seeds.</a:t>
+              <a:t>One atom per customer (4/10/15).</a:t>
             </a:r>
           </a:p>
           <a:p>
@@ -6521,38 +6583,22 @@
               <a:spcAft>
                 <a:spcPts val="900"/>
               </a:spcAft>
-              <a:defRPr sz="2000" b="0">
-                <a:solidFill>
-                  <a:srgbClr val="245B94"/>
+              <a:defRPr sz="1900" b="0">
+                <a:solidFill>
+                  <a:srgbClr val="24292F"/>
                 </a:solidFill>
                 <a:latin typeface="Arial"/>
               </a:defRPr>
             </a:pPr>
             <a:r>
-              <a:t>Nearest-fit decode checks capacity.</a:t>
-            </a:r>
-          </a:p>
-          <a:p>
-            <a:pPr>
-              <a:spcAft>
-                <a:spcPts val="900"/>
-              </a:spcAft>
-              <a:defRPr sz="2000" b="0">
-                <a:solidFill>
-                  <a:srgbClr val="245B94"/>
-                </a:solidFill>
-                <a:latin typeface="Arial"/>
-              </a:defRPr>
-            </a:pPr>
-            <a:r>
-              <a:t>Compare against random K-seed sets.</a:t>
+              <a:t>Distance is the customer distance.</a:t>
             </a:r>
           </a:p>
         </p:txBody>
       </p:sp>
       <p:pic>
         <p:nvPicPr>
-          <p:cNvPr id="13" name="Picture 12" descr="05_expected_loss.png"/>
+          <p:cNvPr id="14" name="Picture 13" descr="05_expected_loss.png"/>
           <p:cNvPicPr>
             <a:picLocks noChangeAspect="1"/>
           </p:cNvPicPr>
@@ -6566,8 +6612,8 @@
         </p:blipFill>
         <p:spPr>
           <a:xfrm>
-            <a:off x="5409144" y="6355080"/>
-            <a:ext cx="3720670" cy="576072"/>
+            <a:off x="4729354" y="6263640"/>
+            <a:ext cx="5080250" cy="777240"/>
           </a:xfrm>
           <a:prstGeom prst="rect">
             <a:avLst/>
@@ -6576,7 +6622,7 @@
       </p:pic>
       <p:sp>
         <p:nvSpPr>
-          <p:cNvPr id="14" name="TextBox 13"/>
+          <p:cNvPr id="15" name="TextBox 14"/>
           <p:cNvSpPr txBox="1"/>
           <p:nvPr/>
         </p:nvSpPr>
@@ -6608,7 +6654,7 @@
               </a:defRPr>
             </a:pPr>
             <a:r>
-              <a:t>M_seed0: baseline target distances and Pulser-valid model B trial layout. No EMU result; report P(F) separately.</a:t>
+              <a:t>M_seed0. Ranks and η are logged runs (PLAN §6). Expected loss is scored on feasible shots; P(F) is reported beside it.</a:t>
             </a:r>
           </a:p>
         </p:txBody>

</xml_diff>